<commit_message>
docs(presentation): explain exhaustive context gate
</commit_message>
<xml_diff>
--- a/docs/Avaya_Case_Review_Suite_Presentation.pptx
+++ b/docs/Avaya_Case_Review_Suite_Presentation.pptx
@@ -2,24 +2,24 @@
 <file path=ppt/presentation.xml><?xml version="1.0" encoding="utf-8"?>
 <p:presentation xmlns:p="http://schemas.openxmlformats.org/presentationml/2006/main">
   <p:sldMasterIdLst>
-    <p:sldMasterId xmlns:r="http://schemas.openxmlformats.org/officeDocument/2006/relationships" id="2147483648" r:id="Rd5fea07f00b5475b"/>
+    <p:sldMasterId xmlns:r="http://schemas.openxmlformats.org/officeDocument/2006/relationships" id="2147483648" r:id="R70b3b0c5ead043ab"/>
   </p:sldMasterIdLst>
   <p:notesMasterIdLst>
-    <p:notesMasterId xmlns:r="http://schemas.openxmlformats.org/officeDocument/2006/relationships" r:id="Rf46bdafe360a409d"/>
+    <p:notesMasterId xmlns:r="http://schemas.openxmlformats.org/officeDocument/2006/relationships" r:id="R7eb0d1c0cd5342c4"/>
   </p:notesMasterIdLst>
   <p:sldIdLst>
-    <p:sldId xmlns:r="http://schemas.openxmlformats.org/officeDocument/2006/relationships" id="256" r:id="Rc8b9e40f567b4d47"/>
-    <p:sldId xmlns:r="http://schemas.openxmlformats.org/officeDocument/2006/relationships" id="257" r:id="Ra39ec4257fce4d45"/>
-    <p:sldId xmlns:r="http://schemas.openxmlformats.org/officeDocument/2006/relationships" id="258" r:id="Rc6f52743773f4547"/>
-    <p:sldId xmlns:r="http://schemas.openxmlformats.org/officeDocument/2006/relationships" id="259" r:id="R282f6ad4cf3c4724"/>
-    <p:sldId xmlns:r="http://schemas.openxmlformats.org/officeDocument/2006/relationships" id="260" r:id="Rc9f8057f9fa54395"/>
-    <p:sldId xmlns:r="http://schemas.openxmlformats.org/officeDocument/2006/relationships" id="261" r:id="R85597d46bd934aff"/>
-    <p:sldId xmlns:r="http://schemas.openxmlformats.org/officeDocument/2006/relationships" id="262" r:id="R4f3ebff47db24b25"/>
-    <p:sldId xmlns:r="http://schemas.openxmlformats.org/officeDocument/2006/relationships" id="263" r:id="R29d900384c2a42ea"/>
-    <p:sldId xmlns:r="http://schemas.openxmlformats.org/officeDocument/2006/relationships" id="264" r:id="R432a4a8dab0a4726"/>
-    <p:sldId xmlns:r="http://schemas.openxmlformats.org/officeDocument/2006/relationships" id="265" r:id="Rabe996d5fb564027"/>
-    <p:sldId xmlns:r="http://schemas.openxmlformats.org/officeDocument/2006/relationships" id="266" r:id="Ra43963e633434997"/>
-    <p:sldId xmlns:r="http://schemas.openxmlformats.org/officeDocument/2006/relationships" id="267" r:id="R11eb7379911f4475"/>
+    <p:sldId xmlns:r="http://schemas.openxmlformats.org/officeDocument/2006/relationships" id="256" r:id="Rb861b2f172114ce0"/>
+    <p:sldId xmlns:r="http://schemas.openxmlformats.org/officeDocument/2006/relationships" id="257" r:id="R9b0db770f19f4028"/>
+    <p:sldId xmlns:r="http://schemas.openxmlformats.org/officeDocument/2006/relationships" id="258" r:id="R42636ecc81e74a8b"/>
+    <p:sldId xmlns:r="http://schemas.openxmlformats.org/officeDocument/2006/relationships" id="259" r:id="R1c6e4cb2d8434dc6"/>
+    <p:sldId xmlns:r="http://schemas.openxmlformats.org/officeDocument/2006/relationships" id="260" r:id="Raad69d6474f949c3"/>
+    <p:sldId xmlns:r="http://schemas.openxmlformats.org/officeDocument/2006/relationships" id="261" r:id="Rdc7d4ca3f9244c69"/>
+    <p:sldId xmlns:r="http://schemas.openxmlformats.org/officeDocument/2006/relationships" id="262" r:id="R610f8638c21641e4"/>
+    <p:sldId xmlns:r="http://schemas.openxmlformats.org/officeDocument/2006/relationships" id="263" r:id="R27a87c5cbf034f8b"/>
+    <p:sldId xmlns:r="http://schemas.openxmlformats.org/officeDocument/2006/relationships" id="264" r:id="Rb5f314d3f7774eb8"/>
+    <p:sldId xmlns:r="http://schemas.openxmlformats.org/officeDocument/2006/relationships" id="265" r:id="Rf53036bb26cc40bd"/>
+    <p:sldId xmlns:r="http://schemas.openxmlformats.org/officeDocument/2006/relationships" id="266" r:id="R57a2b236edc9477b"/>
+    <p:sldId xmlns:r="http://schemas.openxmlformats.org/officeDocument/2006/relationships" id="267" r:id="R64613dea85854bf6"/>
   </p:sldIdLst>
   <p:sldSz cx="12191695" cy="6858000"/>
   <p:notesSz cx="6858000" cy="9144000"/>
@@ -4154,17 +4154,17 @@
   </p:cSld>
   <p:clrMap bg1="lt1" tx1="dk1" bg2="lt2" tx2="dk2" accent1="accent1" accent2="accent2" accent3="accent3" accent4="accent4" accent5="accent5" accent6="accent6" hlink="hlink" folHlink="folHlink"/>
   <p:sldLayoutIdLst>
-    <p:sldLayoutId xmlns:r="http://schemas.openxmlformats.org/officeDocument/2006/relationships" id="2147483649" r:id="R676ae8625f414ebb"/>
-    <p:sldLayoutId xmlns:r="http://schemas.openxmlformats.org/officeDocument/2006/relationships" id="2147483650" r:id="Rdfc486590b1041ae"/>
-    <p:sldLayoutId xmlns:r="http://schemas.openxmlformats.org/officeDocument/2006/relationships" id="2147483651" r:id="R8779a83f6e57426b"/>
-    <p:sldLayoutId xmlns:r="http://schemas.openxmlformats.org/officeDocument/2006/relationships" id="2147483652" r:id="R208f99898e434f26"/>
-    <p:sldLayoutId xmlns:r="http://schemas.openxmlformats.org/officeDocument/2006/relationships" id="2147483653" r:id="R29b1011846874a53"/>
-    <p:sldLayoutId xmlns:r="http://schemas.openxmlformats.org/officeDocument/2006/relationships" id="2147483654" r:id="Ra69d8749e95c4da9"/>
-    <p:sldLayoutId xmlns:r="http://schemas.openxmlformats.org/officeDocument/2006/relationships" id="2147483655" r:id="R4a791fb4286345fd"/>
-    <p:sldLayoutId xmlns:r="http://schemas.openxmlformats.org/officeDocument/2006/relationships" id="2147483656" r:id="R72ded17248a24b0c"/>
-    <p:sldLayoutId xmlns:r="http://schemas.openxmlformats.org/officeDocument/2006/relationships" id="2147483657" r:id="Rb832d290be4a4bdd"/>
-    <p:sldLayoutId xmlns:r="http://schemas.openxmlformats.org/officeDocument/2006/relationships" id="2147483658" r:id="R418e64ec7623480e"/>
-    <p:sldLayoutId xmlns:r="http://schemas.openxmlformats.org/officeDocument/2006/relationships" id="2147483659" r:id="Rbbe3b99b4adf4e2c"/>
+    <p:sldLayoutId xmlns:r="http://schemas.openxmlformats.org/officeDocument/2006/relationships" id="2147483649" r:id="Ref3c9e3c1d304d19"/>
+    <p:sldLayoutId xmlns:r="http://schemas.openxmlformats.org/officeDocument/2006/relationships" id="2147483650" r:id="Rd28e985dabf04b61"/>
+    <p:sldLayoutId xmlns:r="http://schemas.openxmlformats.org/officeDocument/2006/relationships" id="2147483651" r:id="R59b858a6f03a4cf1"/>
+    <p:sldLayoutId xmlns:r="http://schemas.openxmlformats.org/officeDocument/2006/relationships" id="2147483652" r:id="R70aeb3c788584c91"/>
+    <p:sldLayoutId xmlns:r="http://schemas.openxmlformats.org/officeDocument/2006/relationships" id="2147483653" r:id="Rb31550fdc2da452f"/>
+    <p:sldLayoutId xmlns:r="http://schemas.openxmlformats.org/officeDocument/2006/relationships" id="2147483654" r:id="Ra8081577e74e459e"/>
+    <p:sldLayoutId xmlns:r="http://schemas.openxmlformats.org/officeDocument/2006/relationships" id="2147483655" r:id="R5774c221026441b5"/>
+    <p:sldLayoutId xmlns:r="http://schemas.openxmlformats.org/officeDocument/2006/relationships" id="2147483656" r:id="Rc1303ce4036b45b3"/>
+    <p:sldLayoutId xmlns:r="http://schemas.openxmlformats.org/officeDocument/2006/relationships" id="2147483657" r:id="Rd7f06d9f90114198"/>
+    <p:sldLayoutId xmlns:r="http://schemas.openxmlformats.org/officeDocument/2006/relationships" id="2147483658" r:id="R3d8c3f9e5fe74978"/>
+    <p:sldLayoutId xmlns:r="http://schemas.openxmlformats.org/officeDocument/2006/relationships" id="2147483659" r:id="R605aa2586d48433a"/>
   </p:sldLayoutIdLst>
   <p:txStyles>
     <p:titleStyle>
@@ -10203,7 +10203,7 @@
               </a:defRPr>
             </a:pPr>
             <a:r>
-              <a:t>Step 2: Case-Bounded Gmail Retrieval</a:t>
+              <a:t>Step 2: Complete Context Before Analysis</a:t>
             </a:r>
           </a:p>
           <a:p xmlns:a="http://schemas.openxmlformats.org/drawingml/2006/main">
@@ -10216,7 +10216,7 @@
               </a:defRPr>
             </a:pPr>
             <a:r>
-              <a:t>Searches @avaya.com Gmail for the case ID and related task IDs, then contributes retrieved messages to the evidence set.</a:t>
+              <a:t>Freeze the primary and Case-note-related IDs. Every Case note is processed. Every message in every matched Gmail thread is read under one snapshot. Incomplete collection blocks the review. Attachments are excluded.</a:t>
             </a:r>
           </a:p>
         </p:txBody>

</xml_diff>

<commit_message>
fix(presentation): clarify attachment payload scope
</commit_message>
<xml_diff>
--- a/docs/Avaya_Case_Review_Suite_Presentation.pptx
+++ b/docs/Avaya_Case_Review_Suite_Presentation.pptx
@@ -2,24 +2,24 @@
 <file path=ppt/presentation.xml><?xml version="1.0" encoding="utf-8"?>
 <p:presentation xmlns:p="http://schemas.openxmlformats.org/presentationml/2006/main">
   <p:sldMasterIdLst>
-    <p:sldMasterId xmlns:r="http://schemas.openxmlformats.org/officeDocument/2006/relationships" id="2147483648" r:id="R70b3b0c5ead043ab"/>
+    <p:sldMasterId xmlns:r="http://schemas.openxmlformats.org/officeDocument/2006/relationships" id="2147483648" r:id="Rd9c69b6e2bd845f8"/>
   </p:sldMasterIdLst>
   <p:notesMasterIdLst>
-    <p:notesMasterId xmlns:r="http://schemas.openxmlformats.org/officeDocument/2006/relationships" r:id="R7eb0d1c0cd5342c4"/>
+    <p:notesMasterId xmlns:r="http://schemas.openxmlformats.org/officeDocument/2006/relationships" r:id="R260621a8bfdc4d80"/>
   </p:notesMasterIdLst>
   <p:sldIdLst>
-    <p:sldId xmlns:r="http://schemas.openxmlformats.org/officeDocument/2006/relationships" id="256" r:id="Rb861b2f172114ce0"/>
-    <p:sldId xmlns:r="http://schemas.openxmlformats.org/officeDocument/2006/relationships" id="257" r:id="R9b0db770f19f4028"/>
-    <p:sldId xmlns:r="http://schemas.openxmlformats.org/officeDocument/2006/relationships" id="258" r:id="R42636ecc81e74a8b"/>
-    <p:sldId xmlns:r="http://schemas.openxmlformats.org/officeDocument/2006/relationships" id="259" r:id="R1c6e4cb2d8434dc6"/>
-    <p:sldId xmlns:r="http://schemas.openxmlformats.org/officeDocument/2006/relationships" id="260" r:id="Raad69d6474f949c3"/>
-    <p:sldId xmlns:r="http://schemas.openxmlformats.org/officeDocument/2006/relationships" id="261" r:id="Rdc7d4ca3f9244c69"/>
-    <p:sldId xmlns:r="http://schemas.openxmlformats.org/officeDocument/2006/relationships" id="262" r:id="R610f8638c21641e4"/>
-    <p:sldId xmlns:r="http://schemas.openxmlformats.org/officeDocument/2006/relationships" id="263" r:id="R27a87c5cbf034f8b"/>
-    <p:sldId xmlns:r="http://schemas.openxmlformats.org/officeDocument/2006/relationships" id="264" r:id="Rb5f314d3f7774eb8"/>
-    <p:sldId xmlns:r="http://schemas.openxmlformats.org/officeDocument/2006/relationships" id="265" r:id="Rf53036bb26cc40bd"/>
-    <p:sldId xmlns:r="http://schemas.openxmlformats.org/officeDocument/2006/relationships" id="266" r:id="R57a2b236edc9477b"/>
-    <p:sldId xmlns:r="http://schemas.openxmlformats.org/officeDocument/2006/relationships" id="267" r:id="R64613dea85854bf6"/>
+    <p:sldId xmlns:r="http://schemas.openxmlformats.org/officeDocument/2006/relationships" id="256" r:id="Rcabcb3f7084b4590"/>
+    <p:sldId xmlns:r="http://schemas.openxmlformats.org/officeDocument/2006/relationships" id="257" r:id="R5358ed39e3884c9b"/>
+    <p:sldId xmlns:r="http://schemas.openxmlformats.org/officeDocument/2006/relationships" id="258" r:id="R8e08df4f0dea4924"/>
+    <p:sldId xmlns:r="http://schemas.openxmlformats.org/officeDocument/2006/relationships" id="259" r:id="R5b2e44b1dc3b4063"/>
+    <p:sldId xmlns:r="http://schemas.openxmlformats.org/officeDocument/2006/relationships" id="260" r:id="R8cd722ede72a4f6d"/>
+    <p:sldId xmlns:r="http://schemas.openxmlformats.org/officeDocument/2006/relationships" id="261" r:id="R080bf5c15ff34780"/>
+    <p:sldId xmlns:r="http://schemas.openxmlformats.org/officeDocument/2006/relationships" id="262" r:id="R53a0e5e112634e53"/>
+    <p:sldId xmlns:r="http://schemas.openxmlformats.org/officeDocument/2006/relationships" id="263" r:id="Ra898d7f70421423b"/>
+    <p:sldId xmlns:r="http://schemas.openxmlformats.org/officeDocument/2006/relationships" id="264" r:id="Rdd918f38946e4012"/>
+    <p:sldId xmlns:r="http://schemas.openxmlformats.org/officeDocument/2006/relationships" id="265" r:id="R2c41f498a8554c7f"/>
+    <p:sldId xmlns:r="http://schemas.openxmlformats.org/officeDocument/2006/relationships" id="266" r:id="R21d53e2f70274db6"/>
+    <p:sldId xmlns:r="http://schemas.openxmlformats.org/officeDocument/2006/relationships" id="267" r:id="R15037c2c1b8647c9"/>
   </p:sldIdLst>
   <p:sldSz cx="12191695" cy="6858000"/>
   <p:notesSz cx="6858000" cy="9144000"/>
@@ -4154,17 +4154,17 @@
   </p:cSld>
   <p:clrMap bg1="lt1" tx1="dk1" bg2="lt2" tx2="dk2" accent1="accent1" accent2="accent2" accent3="accent3" accent4="accent4" accent5="accent5" accent6="accent6" hlink="hlink" folHlink="folHlink"/>
   <p:sldLayoutIdLst>
-    <p:sldLayoutId xmlns:r="http://schemas.openxmlformats.org/officeDocument/2006/relationships" id="2147483649" r:id="Ref3c9e3c1d304d19"/>
-    <p:sldLayoutId xmlns:r="http://schemas.openxmlformats.org/officeDocument/2006/relationships" id="2147483650" r:id="Rd28e985dabf04b61"/>
-    <p:sldLayoutId xmlns:r="http://schemas.openxmlformats.org/officeDocument/2006/relationships" id="2147483651" r:id="R59b858a6f03a4cf1"/>
-    <p:sldLayoutId xmlns:r="http://schemas.openxmlformats.org/officeDocument/2006/relationships" id="2147483652" r:id="R70aeb3c788584c91"/>
-    <p:sldLayoutId xmlns:r="http://schemas.openxmlformats.org/officeDocument/2006/relationships" id="2147483653" r:id="Rb31550fdc2da452f"/>
-    <p:sldLayoutId xmlns:r="http://schemas.openxmlformats.org/officeDocument/2006/relationships" id="2147483654" r:id="Ra8081577e74e459e"/>
-    <p:sldLayoutId xmlns:r="http://schemas.openxmlformats.org/officeDocument/2006/relationships" id="2147483655" r:id="R5774c221026441b5"/>
-    <p:sldLayoutId xmlns:r="http://schemas.openxmlformats.org/officeDocument/2006/relationships" id="2147483656" r:id="Rc1303ce4036b45b3"/>
-    <p:sldLayoutId xmlns:r="http://schemas.openxmlformats.org/officeDocument/2006/relationships" id="2147483657" r:id="Rd7f06d9f90114198"/>
-    <p:sldLayoutId xmlns:r="http://schemas.openxmlformats.org/officeDocument/2006/relationships" id="2147483658" r:id="R3d8c3f9e5fe74978"/>
-    <p:sldLayoutId xmlns:r="http://schemas.openxmlformats.org/officeDocument/2006/relationships" id="2147483659" r:id="R605aa2586d48433a"/>
+    <p:sldLayoutId xmlns:r="http://schemas.openxmlformats.org/officeDocument/2006/relationships" id="2147483649" r:id="Rbf5bf2d33dec4a2f"/>
+    <p:sldLayoutId xmlns:r="http://schemas.openxmlformats.org/officeDocument/2006/relationships" id="2147483650" r:id="R6ca3a2642fd34a6b"/>
+    <p:sldLayoutId xmlns:r="http://schemas.openxmlformats.org/officeDocument/2006/relationships" id="2147483651" r:id="Rd46bc6b2c8c24a05"/>
+    <p:sldLayoutId xmlns:r="http://schemas.openxmlformats.org/officeDocument/2006/relationships" id="2147483652" r:id="R4b715a46b0bb495c"/>
+    <p:sldLayoutId xmlns:r="http://schemas.openxmlformats.org/officeDocument/2006/relationships" id="2147483653" r:id="R6afc908667524103"/>
+    <p:sldLayoutId xmlns:r="http://schemas.openxmlformats.org/officeDocument/2006/relationships" id="2147483654" r:id="Rdc47a08e668948c9"/>
+    <p:sldLayoutId xmlns:r="http://schemas.openxmlformats.org/officeDocument/2006/relationships" id="2147483655" r:id="Rf08dd2bf584843d1"/>
+    <p:sldLayoutId xmlns:r="http://schemas.openxmlformats.org/officeDocument/2006/relationships" id="2147483656" r:id="R336734b83195429e"/>
+    <p:sldLayoutId xmlns:r="http://schemas.openxmlformats.org/officeDocument/2006/relationships" id="2147483657" r:id="R4ed610843a8e4a4d"/>
+    <p:sldLayoutId xmlns:r="http://schemas.openxmlformats.org/officeDocument/2006/relationships" id="2147483658" r:id="R0fa85e1d59fe45cc"/>
+    <p:sldLayoutId xmlns:r="http://schemas.openxmlformats.org/officeDocument/2006/relationships" id="2147483659" r:id="Rb768ba98cc6245a1"/>
   </p:sldLayoutIdLst>
   <p:txStyles>
     <p:titleStyle>
@@ -10216,7 +10216,10 @@
               </a:defRPr>
             </a:pPr>
             <a:r>
-              <a:t>Freeze the primary and Case-note-related IDs. Every Case note is processed. Every message in every matched Gmail thread is read under one snapshot. Incomplete collection blocks the review. Attachments are excluded.</a:t>
+              <a:t>Freeze the primary and Case-note-related IDs. Every Case note is processed. Every message in every matched Gmail thread is read under one snapshot. Incomplete collection blocks the review. </a:t>
+            </a:r>
+            <a:r>
+              <a:t>Attachment payloads are excluded; filenames and MIME metadata may be recorded.</a:t>
             </a:r>
           </a:p>
         </p:txBody>

</xml_diff>

<commit_message>
perf(case-review): query Gmail by primary case only
</commit_message>
<xml_diff>
--- a/docs/Avaya_Case_Review_Suite_Presentation.pptx
+++ b/docs/Avaya_Case_Review_Suite_Presentation.pptx
@@ -2,24 +2,24 @@
 <file path=ppt/presentation.xml><?xml version="1.0" encoding="utf-8"?>
 <p:presentation xmlns:p="http://schemas.openxmlformats.org/presentationml/2006/main">
   <p:sldMasterIdLst>
-    <p:sldMasterId xmlns:r="http://schemas.openxmlformats.org/officeDocument/2006/relationships" id="2147483648" r:id="Rd9c69b6e2bd845f8"/>
+    <p:sldMasterId xmlns:r="http://schemas.openxmlformats.org/officeDocument/2006/relationships" id="2147483648" r:id="Rd03f41623d4947be"/>
   </p:sldMasterIdLst>
   <p:notesMasterIdLst>
-    <p:notesMasterId xmlns:r="http://schemas.openxmlformats.org/officeDocument/2006/relationships" r:id="R260621a8bfdc4d80"/>
+    <p:notesMasterId xmlns:r="http://schemas.openxmlformats.org/officeDocument/2006/relationships" r:id="R634446edc3fe4e25"/>
   </p:notesMasterIdLst>
   <p:sldIdLst>
-    <p:sldId xmlns:r="http://schemas.openxmlformats.org/officeDocument/2006/relationships" id="256" r:id="Rcabcb3f7084b4590"/>
-    <p:sldId xmlns:r="http://schemas.openxmlformats.org/officeDocument/2006/relationships" id="257" r:id="R5358ed39e3884c9b"/>
-    <p:sldId xmlns:r="http://schemas.openxmlformats.org/officeDocument/2006/relationships" id="258" r:id="R8e08df4f0dea4924"/>
-    <p:sldId xmlns:r="http://schemas.openxmlformats.org/officeDocument/2006/relationships" id="259" r:id="R5b2e44b1dc3b4063"/>
-    <p:sldId xmlns:r="http://schemas.openxmlformats.org/officeDocument/2006/relationships" id="260" r:id="R8cd722ede72a4f6d"/>
-    <p:sldId xmlns:r="http://schemas.openxmlformats.org/officeDocument/2006/relationships" id="261" r:id="R080bf5c15ff34780"/>
-    <p:sldId xmlns:r="http://schemas.openxmlformats.org/officeDocument/2006/relationships" id="262" r:id="R53a0e5e112634e53"/>
-    <p:sldId xmlns:r="http://schemas.openxmlformats.org/officeDocument/2006/relationships" id="263" r:id="Ra898d7f70421423b"/>
-    <p:sldId xmlns:r="http://schemas.openxmlformats.org/officeDocument/2006/relationships" id="264" r:id="Rdd918f38946e4012"/>
-    <p:sldId xmlns:r="http://schemas.openxmlformats.org/officeDocument/2006/relationships" id="265" r:id="R2c41f498a8554c7f"/>
-    <p:sldId xmlns:r="http://schemas.openxmlformats.org/officeDocument/2006/relationships" id="266" r:id="R21d53e2f70274db6"/>
-    <p:sldId xmlns:r="http://schemas.openxmlformats.org/officeDocument/2006/relationships" id="267" r:id="R15037c2c1b8647c9"/>
+    <p:sldId xmlns:r="http://schemas.openxmlformats.org/officeDocument/2006/relationships" id="256" r:id="R4115f8ee2cf6476c"/>
+    <p:sldId xmlns:r="http://schemas.openxmlformats.org/officeDocument/2006/relationships" id="257" r:id="R277deec367e14dec"/>
+    <p:sldId xmlns:r="http://schemas.openxmlformats.org/officeDocument/2006/relationships" id="258" r:id="R4bbb90d62e0d477f"/>
+    <p:sldId xmlns:r="http://schemas.openxmlformats.org/officeDocument/2006/relationships" id="259" r:id="R42d5b56eaa91491c"/>
+    <p:sldId xmlns:r="http://schemas.openxmlformats.org/officeDocument/2006/relationships" id="260" r:id="R291d913084db4193"/>
+    <p:sldId xmlns:r="http://schemas.openxmlformats.org/officeDocument/2006/relationships" id="261" r:id="R15b01e85edb34677"/>
+    <p:sldId xmlns:r="http://schemas.openxmlformats.org/officeDocument/2006/relationships" id="262" r:id="R977c15a06b0a4ac9"/>
+    <p:sldId xmlns:r="http://schemas.openxmlformats.org/officeDocument/2006/relationships" id="263" r:id="R6f13159c387a4a3b"/>
+    <p:sldId xmlns:r="http://schemas.openxmlformats.org/officeDocument/2006/relationships" id="264" r:id="R310798790bca487b"/>
+    <p:sldId xmlns:r="http://schemas.openxmlformats.org/officeDocument/2006/relationships" id="265" r:id="R746ae0a81c654954"/>
+    <p:sldId xmlns:r="http://schemas.openxmlformats.org/officeDocument/2006/relationships" id="266" r:id="R78c760f9aa734266"/>
+    <p:sldId xmlns:r="http://schemas.openxmlformats.org/officeDocument/2006/relationships" id="267" r:id="R3daf3967730b44c4"/>
   </p:sldIdLst>
   <p:sldSz cx="12191695" cy="6858000"/>
   <p:notesSz cx="6858000" cy="9144000"/>
@@ -4154,17 +4154,17 @@
   </p:cSld>
   <p:clrMap bg1="lt1" tx1="dk1" bg2="lt2" tx2="dk2" accent1="accent1" accent2="accent2" accent3="accent3" accent4="accent4" accent5="accent5" accent6="accent6" hlink="hlink" folHlink="folHlink"/>
   <p:sldLayoutIdLst>
-    <p:sldLayoutId xmlns:r="http://schemas.openxmlformats.org/officeDocument/2006/relationships" id="2147483649" r:id="Rbf5bf2d33dec4a2f"/>
-    <p:sldLayoutId xmlns:r="http://schemas.openxmlformats.org/officeDocument/2006/relationships" id="2147483650" r:id="R6ca3a2642fd34a6b"/>
-    <p:sldLayoutId xmlns:r="http://schemas.openxmlformats.org/officeDocument/2006/relationships" id="2147483651" r:id="Rd46bc6b2c8c24a05"/>
-    <p:sldLayoutId xmlns:r="http://schemas.openxmlformats.org/officeDocument/2006/relationships" id="2147483652" r:id="R4b715a46b0bb495c"/>
-    <p:sldLayoutId xmlns:r="http://schemas.openxmlformats.org/officeDocument/2006/relationships" id="2147483653" r:id="R6afc908667524103"/>
-    <p:sldLayoutId xmlns:r="http://schemas.openxmlformats.org/officeDocument/2006/relationships" id="2147483654" r:id="Rdc47a08e668948c9"/>
-    <p:sldLayoutId xmlns:r="http://schemas.openxmlformats.org/officeDocument/2006/relationships" id="2147483655" r:id="Rf08dd2bf584843d1"/>
-    <p:sldLayoutId xmlns:r="http://schemas.openxmlformats.org/officeDocument/2006/relationships" id="2147483656" r:id="R336734b83195429e"/>
-    <p:sldLayoutId xmlns:r="http://schemas.openxmlformats.org/officeDocument/2006/relationships" id="2147483657" r:id="R4ed610843a8e4a4d"/>
-    <p:sldLayoutId xmlns:r="http://schemas.openxmlformats.org/officeDocument/2006/relationships" id="2147483658" r:id="R0fa85e1d59fe45cc"/>
-    <p:sldLayoutId xmlns:r="http://schemas.openxmlformats.org/officeDocument/2006/relationships" id="2147483659" r:id="Rb768ba98cc6245a1"/>
+    <p:sldLayoutId xmlns:r="http://schemas.openxmlformats.org/officeDocument/2006/relationships" id="2147483649" r:id="R56ebdd6767194189"/>
+    <p:sldLayoutId xmlns:r="http://schemas.openxmlformats.org/officeDocument/2006/relationships" id="2147483650" r:id="Re0d51befcbb54f95"/>
+    <p:sldLayoutId xmlns:r="http://schemas.openxmlformats.org/officeDocument/2006/relationships" id="2147483651" r:id="R1028c208ddae4206"/>
+    <p:sldLayoutId xmlns:r="http://schemas.openxmlformats.org/officeDocument/2006/relationships" id="2147483652" r:id="R346bbee312924995"/>
+    <p:sldLayoutId xmlns:r="http://schemas.openxmlformats.org/officeDocument/2006/relationships" id="2147483653" r:id="R0c49be0f2420408b"/>
+    <p:sldLayoutId xmlns:r="http://schemas.openxmlformats.org/officeDocument/2006/relationships" id="2147483654" r:id="Rb4ffc71a07eb439c"/>
+    <p:sldLayoutId xmlns:r="http://schemas.openxmlformats.org/officeDocument/2006/relationships" id="2147483655" r:id="R11d4283c8cd74662"/>
+    <p:sldLayoutId xmlns:r="http://schemas.openxmlformats.org/officeDocument/2006/relationships" id="2147483656" r:id="R71cc3de2dcab40f5"/>
+    <p:sldLayoutId xmlns:r="http://schemas.openxmlformats.org/officeDocument/2006/relationships" id="2147483657" r:id="R81a8c5797eeb4d9f"/>
+    <p:sldLayoutId xmlns:r="http://schemas.openxmlformats.org/officeDocument/2006/relationships" id="2147483658" r:id="Rccd1f538d43a4460"/>
+    <p:sldLayoutId xmlns:r="http://schemas.openxmlformats.org/officeDocument/2006/relationships" id="2147483659" r:id="Rc18347c7a70f47ca"/>
   </p:sldLayoutIdLst>
   <p:txStyles>
     <p:titleStyle>
@@ -10216,7 +10216,16 @@
               </a:defRPr>
             </a:pPr>
             <a:r>
-              <a:t>Freeze the primary and Case-note-related IDs. Every Case note is processed. Every message in every matched Gmail thread is read under one snapshot. Incomplete collection blocks the review. </a:t>
+              <a:t>Query Gmail with the primary raw Case ID only; retain related IDs as Case context.</a:t>
+            </a:r>
+            <a:r>
+              <a:t> Every Case note is processed. </a:t>
+            </a:r>
+            <a:r>
+              <a:t>Every message in every primary-ID-matched Gmail thread</a:t>
+            </a:r>
+            <a:r>
+              <a:t> is read under one snapshot. Incomplete collection blocks the review. </a:t>
             </a:r>
             <a:r>
               <a:t>Attachment payloads are excluded; filenames and MIME metadata may be recorded.</a:t>

</xml_diff>

<commit_message>
✨ feat: expand case review and audit workflows
Restore investigation-complete standard and follow-up outputs with progress flow, causal assessment, timeline, detailed evidence, durable records, and final-output integrity.

Add the separate alarm-audit workflow, refine item-based Technical Plus scoring, harden config-migration profile checks, and synchronize the canonical skills, documentation, presentation, and regression coverage.
</commit_message>
<xml_diff>
--- a/docs/Avaya_Case_Review_Suite_Presentation.pptx
+++ b/docs/Avaya_Case_Review_Suite_Presentation.pptx
@@ -2,24 +2,24 @@
 <file path=ppt/presentation.xml><?xml version="1.0" encoding="utf-8"?>
 <p:presentation xmlns:p="http://schemas.openxmlformats.org/presentationml/2006/main">
   <p:sldMasterIdLst>
-    <p:sldMasterId xmlns:r="http://schemas.openxmlformats.org/officeDocument/2006/relationships" id="2147483648" r:id="Rd03f41623d4947be"/>
+    <p:sldMasterId xmlns:r="http://schemas.openxmlformats.org/officeDocument/2006/relationships" id="2147483648" r:id="R370d01c2077c4de7"/>
   </p:sldMasterIdLst>
   <p:notesMasterIdLst>
-    <p:notesMasterId xmlns:r="http://schemas.openxmlformats.org/officeDocument/2006/relationships" r:id="R634446edc3fe4e25"/>
+    <p:notesMasterId xmlns:r="http://schemas.openxmlformats.org/officeDocument/2006/relationships" r:id="R043e001f6d67401b"/>
   </p:notesMasterIdLst>
   <p:sldIdLst>
-    <p:sldId xmlns:r="http://schemas.openxmlformats.org/officeDocument/2006/relationships" id="256" r:id="R4115f8ee2cf6476c"/>
-    <p:sldId xmlns:r="http://schemas.openxmlformats.org/officeDocument/2006/relationships" id="257" r:id="R277deec367e14dec"/>
-    <p:sldId xmlns:r="http://schemas.openxmlformats.org/officeDocument/2006/relationships" id="258" r:id="R4bbb90d62e0d477f"/>
-    <p:sldId xmlns:r="http://schemas.openxmlformats.org/officeDocument/2006/relationships" id="259" r:id="R42d5b56eaa91491c"/>
-    <p:sldId xmlns:r="http://schemas.openxmlformats.org/officeDocument/2006/relationships" id="260" r:id="R291d913084db4193"/>
-    <p:sldId xmlns:r="http://schemas.openxmlformats.org/officeDocument/2006/relationships" id="261" r:id="R15b01e85edb34677"/>
-    <p:sldId xmlns:r="http://schemas.openxmlformats.org/officeDocument/2006/relationships" id="262" r:id="R977c15a06b0a4ac9"/>
-    <p:sldId xmlns:r="http://schemas.openxmlformats.org/officeDocument/2006/relationships" id="263" r:id="R6f13159c387a4a3b"/>
-    <p:sldId xmlns:r="http://schemas.openxmlformats.org/officeDocument/2006/relationships" id="264" r:id="R310798790bca487b"/>
-    <p:sldId xmlns:r="http://schemas.openxmlformats.org/officeDocument/2006/relationships" id="265" r:id="R746ae0a81c654954"/>
-    <p:sldId xmlns:r="http://schemas.openxmlformats.org/officeDocument/2006/relationships" id="266" r:id="R78c760f9aa734266"/>
-    <p:sldId xmlns:r="http://schemas.openxmlformats.org/officeDocument/2006/relationships" id="267" r:id="R3daf3967730b44c4"/>
+    <p:sldId xmlns:r="http://schemas.openxmlformats.org/officeDocument/2006/relationships" id="256" r:id="R08ce11880fe94d34"/>
+    <p:sldId xmlns:r="http://schemas.openxmlformats.org/officeDocument/2006/relationships" id="257" r:id="R95e52b09775943a8"/>
+    <p:sldId xmlns:r="http://schemas.openxmlformats.org/officeDocument/2006/relationships" id="258" r:id="R6fd84978303c43c9"/>
+    <p:sldId xmlns:r="http://schemas.openxmlformats.org/officeDocument/2006/relationships" id="259" r:id="Rd58cd3cd76134aa3"/>
+    <p:sldId xmlns:r="http://schemas.openxmlformats.org/officeDocument/2006/relationships" id="260" r:id="R5f68fe322a594f5b"/>
+    <p:sldId xmlns:r="http://schemas.openxmlformats.org/officeDocument/2006/relationships" id="261" r:id="Rf4974e0d28644644"/>
+    <p:sldId xmlns:r="http://schemas.openxmlformats.org/officeDocument/2006/relationships" id="262" r:id="Rebebf8e28dc74114"/>
+    <p:sldId xmlns:r="http://schemas.openxmlformats.org/officeDocument/2006/relationships" id="263" r:id="Rb7455323734847b4"/>
+    <p:sldId xmlns:r="http://schemas.openxmlformats.org/officeDocument/2006/relationships" id="264" r:id="R504ba2122c6b4c7a"/>
+    <p:sldId xmlns:r="http://schemas.openxmlformats.org/officeDocument/2006/relationships" id="265" r:id="R479feaca0c73498f"/>
+    <p:sldId xmlns:r="http://schemas.openxmlformats.org/officeDocument/2006/relationships" id="266" r:id="R20dd9f18a9be4a36"/>
+    <p:sldId xmlns:r="http://schemas.openxmlformats.org/officeDocument/2006/relationships" id="267" r:id="Rf3d2e7e01b544cde"/>
   </p:sldIdLst>
   <p:sldSz cx="12191695" cy="6858000"/>
   <p:notesSz cx="6858000" cy="9144000"/>
@@ -540,7 +540,21 @@
         <p:txBody>
           <a:bodyPr xmlns:a="http://schemas.openxmlformats.org/drawingml/2006/main"/>
           <a:lstStyle xmlns:a="http://schemas.openxmlformats.org/drawingml/2006/main"/>
-          <a:p xmlns:a="http://schemas.openxmlformats.org/drawingml/2006/main"/>
+          <a:p xmlns:a="http://schemas.openxmlformats.org/drawingml/2006/main">
+            <a:r>
+              <a:t>[Sources]</a:t>
+            </a:r>
+          </a:p>
+          <a:p xmlns:a="http://schemas.openxmlformats.org/drawingml/2006/main">
+            <a:r>
+              <a:t>- Repository case-review output contract (local source)</a:t>
+            </a:r>
+          </a:p>
+          <a:p xmlns:a="http://schemas.openxmlformats.org/drawingml/2006/main">
+            <a:r>
+              <a:t>[/Sources]</a:t>
+            </a:r>
+          </a:p>
         </p:txBody>
       </p:sp>
       <p:sp>
@@ -1134,7 +1148,21 @@
         <p:txBody>
           <a:bodyPr xmlns:a="http://schemas.openxmlformats.org/drawingml/2006/main"/>
           <a:lstStyle xmlns:a="http://schemas.openxmlformats.org/drawingml/2006/main"/>
-          <a:p xmlns:a="http://schemas.openxmlformats.org/drawingml/2006/main"/>
+          <a:p xmlns:a="http://schemas.openxmlformats.org/drawingml/2006/main">
+            <a:r>
+              <a:t>[Sources]</a:t>
+            </a:r>
+          </a:p>
+          <a:p xmlns:a="http://schemas.openxmlformats.org/drawingml/2006/main">
+            <a:r>
+              <a:t>- Repository case-review output contract (local source)</a:t>
+            </a:r>
+          </a:p>
+          <a:p xmlns:a="http://schemas.openxmlformats.org/drawingml/2006/main">
+            <a:r>
+              <a:t>[/Sources]</a:t>
+            </a:r>
+          </a:p>
         </p:txBody>
       </p:sp>
       <p:sp>
@@ -4154,17 +4182,17 @@
   </p:cSld>
   <p:clrMap bg1="lt1" tx1="dk1" bg2="lt2" tx2="dk2" accent1="accent1" accent2="accent2" accent3="accent3" accent4="accent4" accent5="accent5" accent6="accent6" hlink="hlink" folHlink="folHlink"/>
   <p:sldLayoutIdLst>
-    <p:sldLayoutId xmlns:r="http://schemas.openxmlformats.org/officeDocument/2006/relationships" id="2147483649" r:id="R56ebdd6767194189"/>
-    <p:sldLayoutId xmlns:r="http://schemas.openxmlformats.org/officeDocument/2006/relationships" id="2147483650" r:id="Re0d51befcbb54f95"/>
-    <p:sldLayoutId xmlns:r="http://schemas.openxmlformats.org/officeDocument/2006/relationships" id="2147483651" r:id="R1028c208ddae4206"/>
-    <p:sldLayoutId xmlns:r="http://schemas.openxmlformats.org/officeDocument/2006/relationships" id="2147483652" r:id="R346bbee312924995"/>
-    <p:sldLayoutId xmlns:r="http://schemas.openxmlformats.org/officeDocument/2006/relationships" id="2147483653" r:id="R0c49be0f2420408b"/>
-    <p:sldLayoutId xmlns:r="http://schemas.openxmlformats.org/officeDocument/2006/relationships" id="2147483654" r:id="Rb4ffc71a07eb439c"/>
-    <p:sldLayoutId xmlns:r="http://schemas.openxmlformats.org/officeDocument/2006/relationships" id="2147483655" r:id="R11d4283c8cd74662"/>
-    <p:sldLayoutId xmlns:r="http://schemas.openxmlformats.org/officeDocument/2006/relationships" id="2147483656" r:id="R71cc3de2dcab40f5"/>
-    <p:sldLayoutId xmlns:r="http://schemas.openxmlformats.org/officeDocument/2006/relationships" id="2147483657" r:id="R81a8c5797eeb4d9f"/>
-    <p:sldLayoutId xmlns:r="http://schemas.openxmlformats.org/officeDocument/2006/relationships" id="2147483658" r:id="Rccd1f538d43a4460"/>
-    <p:sldLayoutId xmlns:r="http://schemas.openxmlformats.org/officeDocument/2006/relationships" id="2147483659" r:id="Rc18347c7a70f47ca"/>
+    <p:sldLayoutId xmlns:r="http://schemas.openxmlformats.org/officeDocument/2006/relationships" id="2147483649" r:id="R24ebb5777b1e421f"/>
+    <p:sldLayoutId xmlns:r="http://schemas.openxmlformats.org/officeDocument/2006/relationships" id="2147483650" r:id="R9f966ac165d44695"/>
+    <p:sldLayoutId xmlns:r="http://schemas.openxmlformats.org/officeDocument/2006/relationships" id="2147483651" r:id="R7a1d423809484b48"/>
+    <p:sldLayoutId xmlns:r="http://schemas.openxmlformats.org/officeDocument/2006/relationships" id="2147483652" r:id="R47a53bd1393c4c76"/>
+    <p:sldLayoutId xmlns:r="http://schemas.openxmlformats.org/officeDocument/2006/relationships" id="2147483653" r:id="R66aa6eda84d544d8"/>
+    <p:sldLayoutId xmlns:r="http://schemas.openxmlformats.org/officeDocument/2006/relationships" id="2147483654" r:id="R337f3c821395404d"/>
+    <p:sldLayoutId xmlns:r="http://schemas.openxmlformats.org/officeDocument/2006/relationships" id="2147483655" r:id="R85cd112df81e48ff"/>
+    <p:sldLayoutId xmlns:r="http://schemas.openxmlformats.org/officeDocument/2006/relationships" id="2147483656" r:id="Rf6d95f6a68f64153"/>
+    <p:sldLayoutId xmlns:r="http://schemas.openxmlformats.org/officeDocument/2006/relationships" id="2147483657" r:id="Rd22d8077a3cb414f"/>
+    <p:sldLayoutId xmlns:r="http://schemas.openxmlformats.org/officeDocument/2006/relationships" id="2147483658" r:id="R238117bd8da84c85"/>
+    <p:sldLayoutId xmlns:r="http://schemas.openxmlformats.org/officeDocument/2006/relationships" id="2147483659" r:id="R01a87251087a4f4b"/>
   </p:sldLayoutIdLst>
   <p:txStyles>
     <p:titleStyle>
@@ -4963,7 +4991,7 @@
               </a:defRPr>
             </a:pPr>
             <a:r>
-              <a:t>Standardized Executive Review Report Structure</a:t>
+              <a:t>Deterministic Case Review Presentation Modes</a:t>
             </a:r>
           </a:p>
         </p:txBody>
@@ -5093,7 +5121,7 @@
         <p:spPr>
           <a:xfrm xmlns:a="http://schemas.openxmlformats.org/drawingml/2006/main">
             <a:off x="868680" y="1353312"/>
-            <a:ext cx="4846320" cy="731520"/>
+            <a:ext cx="4846320" cy="746760"/>
           </a:xfrm>
           <a:prstGeom xmlns:a="http://schemas.openxmlformats.org/drawingml/2006/main" prst="rect">
             <a:avLst/>
@@ -5115,7 +5143,7 @@
               </a:defRPr>
             </a:pPr>
             <a:r>
-              <a:t>1. 6-8 Sentence Executive Summary</a:t>
+              <a:t>1. standard</a:t>
             </a:r>
           </a:p>
           <a:p xmlns:a="http://schemas.openxmlformats.org/drawingml/2006/main">
@@ -5128,7 +5156,7 @@
               </a:defRPr>
             </a:pPr>
             <a:r>
-              <a:t>One conclusion-level paragraph: incident, impact, response, RCA state, mitigation, status, and next checkpoint.</a:t>
+              <a:t>Structured ReviewSnapshot v2 preserves the whole-case storyline through progress flow, Causal Assessment, Timeline, and Evidence Register.</a:t>
             </a:r>
           </a:p>
         </p:txBody>
@@ -5227,7 +5255,7 @@
               </a:defRPr>
             </a:pPr>
             <a:r>
-              <a:t>2. Technical &amp; Incident Assessment</a:t>
+              <a:t>2. compact</a:t>
             </a:r>
           </a:p>
           <a:p xmlns:a="http://schemas.openxmlformats.org/drawingml/2006/main">
@@ -5240,7 +5268,7 @@
               </a:defRPr>
             </a:pPr>
             <a:r>
-              <a:t>Reasoning, findings, validation state, and unresolved gaps without repeating the summary.</a:t>
+              <a:t>Explicit short view only; retains the primary problem, conflict, blocker, owner, and ETA.</a:t>
             </a:r>
           </a:p>
         </p:txBody>
@@ -5339,7 +5367,7 @@
               </a:defRPr>
             </a:pPr>
             <a:r>
-              <a:t>3. Progress Summary</a:t>
+              <a:t>3. follow-up</a:t>
             </a:r>
           </a:p>
           <a:p xmlns:a="http://schemas.openxmlformats.org/drawingml/2006/main">
@@ -5352,7 +5380,7 @@
               </a:defRPr>
             </a:pPr>
             <a:r>
-              <a:t>Substantive progress and validation outcomes across available sources.</a:t>
+              <a:t>Material delta first, then the complete standard investigation; the prior record remains comparison only.</a:t>
             </a:r>
           </a:p>
         </p:txBody>
@@ -5451,7 +5479,7 @@
               </a:defRPr>
             </a:pPr>
             <a:r>
-              <a:t>4. Ownership &amp; Next Step</a:t>
+              <a:t>4. technical</a:t>
             </a:r>
           </a:p>
           <a:p xmlns:a="http://schemas.openxmlformats.org/drawingml/2006/main">
@@ -5464,7 +5492,7 @@
               </a:defRPr>
             </a:pPr>
             <a:r>
-              <a:t>Evidence-stated assignee, last action, next action, owner, and due date.</a:t>
+              <a:t>Fixed proof-state Technical Specification with explicit evidence gaps.</a:t>
             </a:r>
           </a:p>
         </p:txBody>
@@ -5563,7 +5591,7 @@
               </a:defRPr>
             </a:pPr>
             <a:r>
-              <a:t>5. Timeline</a:t>
+              <a:t>5. flow + Adaptive Visual</a:t>
             </a:r>
           </a:p>
           <a:p xmlns:a="http://schemas.openxmlformats.org/drawingml/2006/main">
@@ -5576,7 +5604,7 @@
               </a:defRPr>
             </a:pPr>
             <a:r>
-              <a:t>Dated substantive events, oldest to newest; undated events follow.</a:t>
+              <a:t>Explicit progress flow of evidence-backed state transitions; never replaced by another diagnostic visual.</a:t>
             </a:r>
           </a:p>
         </p:txBody>
@@ -5675,7 +5703,7 @@
               </a:defRPr>
             </a:pPr>
             <a:r>
-              <a:t>6. Appendix A — Evidence Register</a:t>
+              <a:t>6. full</a:t>
             </a:r>
           </a:p>
           <a:p xmlns:a="http://schemas.openxmlformats.org/drawingml/2006/main">
@@ -5688,7 +5716,7 @@
               </a:defRPr>
             </a:pPr>
             <a:r>
-              <a:t>Final reverse-mapped evidence table; no inline citations.</a:t>
+              <a:t>Explicit on-demand view; Appendix A — Evidence Register remains last.</a:t>
             </a:r>
           </a:p>
         </p:txBody>
@@ -11720,7 +11748,7 @@
               </a:defRPr>
             </a:pPr>
             <a:r>
-              <a:t>Evidence-Grounded Technical Assessment (The Engine Brain)</a:t>
+              <a:t>Proof-State Technical Specification (The Engine Brain)</a:t>
             </a:r>
           </a:p>
         </p:txBody>
@@ -11875,7 +11903,7 @@
               </a:defRPr>
             </a:pPr>
             <a:r>
-              <a:t>How Evidence-Grounded Assessment Works</a:t>
+              <a:t>How Evidence-Grounded Technical Review Works</a:t>
             </a:r>
           </a:p>
           <a:p xmlns:a="http://schemas.openxmlformats.org/drawingml/2006/main">
@@ -12100,7 +12128,7 @@
               </a:defRPr>
             </a:pPr>
             <a:r>
-              <a:t>Technical Assessment Example</a:t>
+              <a:t>Technical Specification Example</a:t>
             </a:r>
           </a:p>
           <a:p xmlns:a="http://schemas.openxmlformats.org/drawingml/2006/main">
@@ -12116,54 +12144,19 @@
               </a:defRPr>
             </a:pPr>
             <a:r>
-              <a:t>## Technical &amp; Incident Assessment</a:t>
-            </a:r>
-            <a:br/>
-            <a:br/>
-            <a:r>
-              <a:t>Problem clarification:</a:t>
-            </a:r>
-            <a:br/>
-            <a:r>
-              <a:t>  Missing trunk CLI is reported on a second</a:t>
-            </a:r>
-            <a:br/>
-            <a:r>
-              <a:t>  unpark; scope and reproducibility are not</a:t>
-            </a:r>
-            <a:br/>
-            <a:r>
-              <a:t>  established by the available record.</a:t>
-            </a:r>
-            <a:br/>
-            <a:r>
-              <a:t>Findings:</a:t>
-            </a:r>
-            <a:br/>
-            <a:r>
-              <a:t>  A JTAPI null is recorded; synchronized CM and JTAPI traces are absent.</a:t>
-            </a:r>
-            <a:br/>
-            <a:br/>
-            <a:r>
-              <a:t>Cause state — Under Investigation:</a:t>
-            </a:r>
-            <a:br/>
-            <a:r>
-              <a:t>  CM configuration is a working hypothesis;</a:t>
-            </a:r>
-            <a:br/>
-            <a:r>
-              <a:t>  other paths remain open pending evidence.</a:t>
-            </a:r>
-            <a:br/>
-            <a:br/>
-            <a:r>
-              <a:t>Validation state:</a:t>
-            </a:r>
-            <a:br/>
-            <a:r>
-              <a:t>  No change or customer-confirmed outcome is evidenced.</a:t>
+              <a:t>## Technical Specification
+Scope | UNKNOWN
+  Affected scope is not established.
+Symptom | OBSERVED
+  A JTAPI null return is recorded.
+Confirmed mechanism | NOT OBSERVED
+  Same-event application/CM evidence is absent.
+Suspected or unproven | SUSPECTED
+  CM feature configuration remains a hypothesis.
+Verification | NOT COLLECTED
+  Synchronized traces are missing.
+Production outcome | UNKNOWN
+  No post-change production evidence is present.</a:t>
             </a:r>
           </a:p>
         </p:txBody>

</xml_diff>